<commit_message>
update: update powerpoint template
</commit_message>
<xml_diff>
--- a/app/reporters/ppt_generators/templates/ppt_template.pptx
+++ b/app/reporters/ppt_generators/templates/ppt_template.pptx
@@ -350,6 +350,68 @@
 
 <file path=ppt/slideLayouts/slideLayout2.xml><?xml version="1.0" encoding="utf-8"?>
 <p:sldLayout xmlns:a="http://schemas.openxmlformats.org/drawingml/2006/main" xmlns:r="http://schemas.openxmlformats.org/officeDocument/2006/relationships" xmlns:p="http://schemas.openxmlformats.org/presentationml/2006/main" preserve="1" userDrawn="1">
+  <p:cSld name="Sources Title Slide">
+    <p:spTree>
+      <p:nvGrpSpPr>
+        <p:cNvPr id="1" name=""/>
+        <p:cNvGrpSpPr/>
+        <p:nvPr/>
+      </p:nvGrpSpPr>
+      <p:grpSpPr>
+        <a:xfrm>
+          <a:off x="0" y="0"/>
+          <a:ext cx="0" cy="0"/>
+          <a:chOff x="0" y="0"/>
+          <a:chExt cx="0" cy="0"/>
+        </a:xfrm>
+      </p:grpSpPr>
+      <p:sp>
+        <p:nvSpPr>
+          <p:cNvPr id="2" name="Title 1"/>
+          <p:cNvSpPr>
+            <a:spLocks noGrp="1"/>
+          </p:cNvSpPr>
+          <p:nvPr>
+            <p:ph type="ctrTitle" hasCustomPrompt="1"/>
+          </p:nvPr>
+        </p:nvSpPr>
+        <p:spPr>
+          <a:xfrm>
+            <a:off x="838200" y="2084832"/>
+            <a:ext cx="4315968" cy="2144618"/>
+          </a:xfrm>
+        </p:spPr>
+        <p:txBody>
+          <a:bodyPr anchor="b"/>
+          <a:lstStyle>
+            <a:lvl1pPr algn="l">
+              <a:defRPr sz="6000" b="1" baseline="0"/>
+            </a:lvl1pPr>
+          </a:lstStyle>
+          <a:p>
+            <a:r>
+              <a:rPr lang="en-US" dirty="0" smtClean="0"/>
+              <a:t>MEDIA TYPE</a:t>
+            </a:r>
+            <a:endParaRPr lang="en-US" dirty="0"/>
+          </a:p>
+        </p:txBody>
+      </p:sp>
+    </p:spTree>
+    <p:extLst>
+      <p:ext uri="{BB962C8B-B14F-4D97-AF65-F5344CB8AC3E}">
+        <p14:creationId xmlns:p14="http://schemas.microsoft.com/office/powerpoint/2010/main" val="2074277662"/>
+      </p:ext>
+    </p:extLst>
+  </p:cSld>
+  <p:clrMapOvr>
+    <a:masterClrMapping/>
+  </p:clrMapOvr>
+</p:sldLayout>
+</file>
+
+<file path=ppt/slideLayouts/slideLayout3.xml><?xml version="1.0" encoding="utf-8"?>
+<p:sldLayout xmlns:a="http://schemas.openxmlformats.org/drawingml/2006/main" xmlns:r="http://schemas.openxmlformats.org/officeDocument/2006/relationships" xmlns:p="http://schemas.openxmlformats.org/presentationml/2006/main" preserve="1" userDrawn="1">
   <p:cSld name="Line Charts Slide">
     <p:spTree>
       <p:nvGrpSpPr>
@@ -827,9 +889,9 @@
 </p:sldLayout>
 </file>
 
-<file path=ppt/slideLayouts/slideLayout3.xml><?xml version="1.0" encoding="utf-8"?>
+<file path=ppt/slideLayouts/slideLayout4.xml><?xml version="1.0" encoding="utf-8"?>
 <p:sldLayout xmlns:a="http://schemas.openxmlformats.org/drawingml/2006/main" xmlns:r="http://schemas.openxmlformats.org/officeDocument/2006/relationships" xmlns:p="http://schemas.openxmlformats.org/presentationml/2006/main" preserve="1" userDrawn="1">
-  <p:cSld name="Sentiment Slide">
+  <p:cSld name="Sentiment With Sources Slide">
     <p:spTree>
       <p:nvGrpSpPr>
         <p:cNvPr id="1" name=""/>
@@ -1521,7 +1583,647 @@
 </p:sldLayout>
 </file>
 
-<file path=ppt/slideLayouts/slideLayout4.xml><?xml version="1.0" encoding="utf-8"?>
+<file path=ppt/slideLayouts/slideLayout5.xml><?xml version="1.0" encoding="utf-8"?>
+<p:sldLayout xmlns:a="http://schemas.openxmlformats.org/drawingml/2006/main" xmlns:r="http://schemas.openxmlformats.org/officeDocument/2006/relationships" xmlns:p="http://schemas.openxmlformats.org/presentationml/2006/main" preserve="1" userDrawn="1">
+  <p:cSld name="1_Sentiment Slide">
+    <p:spTree>
+      <p:nvGrpSpPr>
+        <p:cNvPr id="1" name=""/>
+        <p:cNvGrpSpPr/>
+        <p:nvPr/>
+      </p:nvGrpSpPr>
+      <p:grpSpPr>
+        <a:xfrm>
+          <a:off x="0" y="0"/>
+          <a:ext cx="0" cy="0"/>
+          <a:chOff x="0" y="0"/>
+          <a:chExt cx="0" cy="0"/>
+        </a:xfrm>
+      </p:grpSpPr>
+      <p:sp>
+        <p:nvSpPr>
+          <p:cNvPr id="19" name="TextBox 18"/>
+          <p:cNvSpPr txBox="1"/>
+          <p:nvPr userDrawn="1"/>
+        </p:nvSpPr>
+        <p:spPr>
+          <a:xfrm>
+            <a:off x="835534" y="5473249"/>
+            <a:ext cx="1055872" cy="338554"/>
+          </a:xfrm>
+          <a:prstGeom prst="rect">
+            <a:avLst/>
+          </a:prstGeom>
+          <a:noFill/>
+        </p:spPr>
+        <p:txBody>
+          <a:bodyPr wrap="square" rtlCol="0">
+            <a:spAutoFit/>
+          </a:bodyPr>
+          <a:lstStyle/>
+          <a:p>
+            <a:r>
+              <a:rPr lang="en-US" sz="1600" b="1" i="0" baseline="0" dirty="0" smtClean="0"/>
+              <a:t>Mentions</a:t>
+            </a:r>
+            <a:endParaRPr lang="en-US" sz="1600" b="1" i="0" baseline="0" dirty="0"/>
+          </a:p>
+        </p:txBody>
+      </p:sp>
+      <p:sp>
+        <p:nvSpPr>
+          <p:cNvPr id="21" name="TextBox 20"/>
+          <p:cNvSpPr txBox="1"/>
+          <p:nvPr userDrawn="1"/>
+        </p:nvSpPr>
+        <p:spPr>
+          <a:xfrm>
+            <a:off x="8103016" y="2021964"/>
+            <a:ext cx="843885" cy="276999"/>
+          </a:xfrm>
+          <a:prstGeom prst="rect">
+            <a:avLst/>
+          </a:prstGeom>
+          <a:noFill/>
+        </p:spPr>
+        <p:txBody>
+          <a:bodyPr wrap="none" rtlCol="0">
+            <a:spAutoFit/>
+          </a:bodyPr>
+          <a:lstStyle/>
+          <a:p>
+            <a:r>
+              <a:rPr lang="en-US" sz="1200" b="1" i="0" baseline="0" dirty="0" smtClean="0"/>
+              <a:t>Sentiment</a:t>
+            </a:r>
+            <a:endParaRPr lang="en-US" sz="1200" b="1" i="0" baseline="0" dirty="0"/>
+          </a:p>
+        </p:txBody>
+      </p:sp>
+      <p:sp>
+        <p:nvSpPr>
+          <p:cNvPr id="30" name="TextBox 29"/>
+          <p:cNvSpPr txBox="1"/>
+          <p:nvPr userDrawn="1"/>
+        </p:nvSpPr>
+        <p:spPr>
+          <a:xfrm>
+            <a:off x="1359438" y="3106946"/>
+            <a:ext cx="597728" cy="338554"/>
+          </a:xfrm>
+          <a:prstGeom prst="rect">
+            <a:avLst/>
+          </a:prstGeom>
+          <a:noFill/>
+        </p:spPr>
+        <p:txBody>
+          <a:bodyPr wrap="none" rtlCol="0">
+            <a:spAutoFit/>
+          </a:bodyPr>
+          <a:lstStyle/>
+          <a:p>
+            <a:r>
+              <a:rPr lang="en-US" sz="1600" b="0" i="0" baseline="0" dirty="0" smtClean="0">
+                <a:solidFill>
+                  <a:schemeClr val="bg1">
+                    <a:lumMod val="65000"/>
+                  </a:schemeClr>
+                </a:solidFill>
+              </a:rPr>
+              <a:t>Total</a:t>
+            </a:r>
+            <a:endParaRPr lang="en-US" sz="1600" b="0" i="0" baseline="0" dirty="0">
+              <a:solidFill>
+                <a:schemeClr val="bg1">
+                  <a:lumMod val="65000"/>
+                </a:schemeClr>
+              </a:solidFill>
+            </a:endParaRPr>
+          </a:p>
+        </p:txBody>
+      </p:sp>
+      <p:sp>
+        <p:nvSpPr>
+          <p:cNvPr id="31" name="TextBox 30"/>
+          <p:cNvSpPr txBox="1"/>
+          <p:nvPr userDrawn="1"/>
+        </p:nvSpPr>
+        <p:spPr>
+          <a:xfrm>
+            <a:off x="3595859" y="3131525"/>
+            <a:ext cx="830997" cy="338554"/>
+          </a:xfrm>
+          <a:prstGeom prst="rect">
+            <a:avLst/>
+          </a:prstGeom>
+          <a:noFill/>
+        </p:spPr>
+        <p:txBody>
+          <a:bodyPr wrap="none" rtlCol="0">
+            <a:spAutoFit/>
+          </a:bodyPr>
+          <a:lstStyle/>
+          <a:p>
+            <a:r>
+              <a:rPr lang="en-US" sz="1600" b="0" i="0" baseline="0" dirty="0" smtClean="0">
+                <a:solidFill>
+                  <a:schemeClr val="bg1">
+                    <a:lumMod val="65000"/>
+                  </a:schemeClr>
+                </a:solidFill>
+              </a:rPr>
+              <a:t>Positive</a:t>
+            </a:r>
+            <a:endParaRPr lang="en-US" sz="1600" b="0" i="0" baseline="0" dirty="0">
+              <a:solidFill>
+                <a:schemeClr val="bg1">
+                  <a:lumMod val="65000"/>
+                </a:schemeClr>
+              </a:solidFill>
+            </a:endParaRPr>
+          </a:p>
+        </p:txBody>
+      </p:sp>
+      <p:sp>
+        <p:nvSpPr>
+          <p:cNvPr id="32" name="TextBox 31"/>
+          <p:cNvSpPr txBox="1"/>
+          <p:nvPr userDrawn="1"/>
+        </p:nvSpPr>
+        <p:spPr>
+          <a:xfrm>
+            <a:off x="1199523" y="4204511"/>
+            <a:ext cx="917559" cy="338554"/>
+          </a:xfrm>
+          <a:prstGeom prst="rect">
+            <a:avLst/>
+          </a:prstGeom>
+          <a:noFill/>
+        </p:spPr>
+        <p:txBody>
+          <a:bodyPr wrap="none" rtlCol="0">
+            <a:spAutoFit/>
+          </a:bodyPr>
+          <a:lstStyle/>
+          <a:p>
+            <a:r>
+              <a:rPr lang="en-US" sz="1600" b="0" i="0" baseline="0" dirty="0" smtClean="0">
+                <a:solidFill>
+                  <a:schemeClr val="bg1">
+                    <a:lumMod val="65000"/>
+                  </a:schemeClr>
+                </a:solidFill>
+              </a:rPr>
+              <a:t>Negative</a:t>
+            </a:r>
+            <a:endParaRPr lang="en-US" sz="1600" b="0" i="0" baseline="0" dirty="0">
+              <a:solidFill>
+                <a:schemeClr val="bg1">
+                  <a:lumMod val="65000"/>
+                </a:schemeClr>
+              </a:solidFill>
+            </a:endParaRPr>
+          </a:p>
+        </p:txBody>
+      </p:sp>
+      <p:sp>
+        <p:nvSpPr>
+          <p:cNvPr id="18" name="Text Placeholder 3"/>
+          <p:cNvSpPr>
+            <a:spLocks noGrp="1"/>
+          </p:cNvSpPr>
+          <p:nvPr>
+            <p:ph type="body" sz="quarter" idx="20" hasCustomPrompt="1"/>
+          </p:nvPr>
+        </p:nvSpPr>
+        <p:spPr>
+          <a:xfrm>
+            <a:off x="863780" y="958790"/>
+            <a:ext cx="10706428" cy="262234"/>
+          </a:xfrm>
+        </p:spPr>
+        <p:txBody>
+          <a:bodyPr>
+            <a:noAutofit/>
+          </a:bodyPr>
+          <a:lstStyle>
+            <a:lvl1pPr marL="0" indent="0">
+              <a:buNone/>
+              <a:defRPr sz="1800" b="1"/>
+            </a:lvl1pPr>
+          </a:lstStyle>
+          <a:p>
+            <a:pPr lvl="0"/>
+            <a:r>
+              <a:rPr lang="en-US" dirty="0" smtClean="0"/>
+              <a:t>HEADING</a:t>
+            </a:r>
+            <a:endParaRPr lang="en-US" dirty="0"/>
+          </a:p>
+        </p:txBody>
+      </p:sp>
+      <p:sp>
+        <p:nvSpPr>
+          <p:cNvPr id="23" name="Text Placeholder 4"/>
+          <p:cNvSpPr>
+            <a:spLocks noGrp="1"/>
+          </p:cNvSpPr>
+          <p:nvPr>
+            <p:ph type="body" sz="quarter" idx="21" hasCustomPrompt="1"/>
+          </p:nvPr>
+        </p:nvSpPr>
+        <p:spPr>
+          <a:xfrm>
+            <a:off x="835533" y="1411192"/>
+            <a:ext cx="10734675" cy="521562"/>
+          </a:xfrm>
+        </p:spPr>
+        <p:txBody>
+          <a:bodyPr/>
+          <a:lstStyle>
+            <a:lvl1pPr marL="0" indent="0">
+              <a:buNone/>
+              <a:defRPr sz="1600"/>
+            </a:lvl1pPr>
+          </a:lstStyle>
+          <a:p>
+            <a:pPr lvl="0"/>
+            <a:r>
+              <a:rPr lang="en-US" dirty="0" smtClean="0"/>
+              <a:t>Summary</a:t>
+            </a:r>
+            <a:endParaRPr lang="en-US" dirty="0"/>
+          </a:p>
+        </p:txBody>
+      </p:sp>
+      <p:sp>
+        <p:nvSpPr>
+          <p:cNvPr id="24" name="Text Placeholder 4"/>
+          <p:cNvSpPr>
+            <a:spLocks noGrp="1"/>
+          </p:cNvSpPr>
+          <p:nvPr>
+            <p:ph type="body" sz="quarter" idx="22" hasCustomPrompt="1"/>
+          </p:nvPr>
+        </p:nvSpPr>
+        <p:spPr>
+          <a:xfrm>
+            <a:off x="835533" y="5890401"/>
+            <a:ext cx="10734674" cy="840252"/>
+          </a:xfrm>
+        </p:spPr>
+        <p:txBody>
+          <a:bodyPr/>
+          <a:lstStyle>
+            <a:lvl1pPr marL="0" indent="0">
+              <a:buNone/>
+              <a:defRPr sz="1600"/>
+            </a:lvl1pPr>
+          </a:lstStyle>
+          <a:p>
+            <a:pPr lvl="0"/>
+            <a:r>
+              <a:rPr lang="en-US" dirty="0" smtClean="0"/>
+              <a:t>Summary</a:t>
+            </a:r>
+            <a:endParaRPr lang="en-US" dirty="0"/>
+          </a:p>
+        </p:txBody>
+      </p:sp>
+      <p:sp>
+        <p:nvSpPr>
+          <p:cNvPr id="26" name="Chart Placeholder 3"/>
+          <p:cNvSpPr>
+            <a:spLocks noGrp="1"/>
+          </p:cNvSpPr>
+          <p:nvPr>
+            <p:ph type="chart" sz="quarter" idx="24"/>
+          </p:nvPr>
+        </p:nvSpPr>
+        <p:spPr>
+          <a:xfrm>
+            <a:off x="5479712" y="2388173"/>
+            <a:ext cx="6090495" cy="2933700"/>
+          </a:xfrm>
+        </p:spPr>
+        <p:txBody>
+          <a:bodyPr/>
+          <a:lstStyle/>
+          <a:p>
+            <a:endParaRPr lang="en-US"/>
+          </a:p>
+        </p:txBody>
+      </p:sp>
+      <p:sp>
+        <p:nvSpPr>
+          <p:cNvPr id="5" name="Text Placeholder 4"/>
+          <p:cNvSpPr>
+            <a:spLocks noGrp="1"/>
+          </p:cNvSpPr>
+          <p:nvPr>
+            <p:ph type="body" sz="quarter" idx="25" hasCustomPrompt="1"/>
+          </p:nvPr>
+        </p:nvSpPr>
+        <p:spPr>
+          <a:xfrm>
+            <a:off x="835533" y="2783651"/>
+            <a:ext cx="1718563" cy="384255"/>
+          </a:xfrm>
+        </p:spPr>
+        <p:txBody>
+          <a:bodyPr>
+            <a:noAutofit/>
+          </a:bodyPr>
+          <a:lstStyle>
+            <a:lvl1pPr marL="0" indent="0" algn="ctr">
+              <a:buNone/>
+              <a:defRPr sz="2400" b="1"/>
+            </a:lvl1pPr>
+          </a:lstStyle>
+          <a:p>
+            <a:pPr lvl="0"/>
+            <a:r>
+              <a:rPr lang="en-US" dirty="0" smtClean="0"/>
+              <a:t>12345</a:t>
+            </a:r>
+            <a:endParaRPr lang="en-US" dirty="0"/>
+          </a:p>
+        </p:txBody>
+      </p:sp>
+      <p:sp>
+        <p:nvSpPr>
+          <p:cNvPr id="25" name="Text Placeholder 4"/>
+          <p:cNvSpPr>
+            <a:spLocks noGrp="1"/>
+          </p:cNvSpPr>
+          <p:nvPr>
+            <p:ph type="body" sz="quarter" idx="26" hasCustomPrompt="1"/>
+          </p:nvPr>
+        </p:nvSpPr>
+        <p:spPr>
+          <a:xfrm>
+            <a:off x="3188588" y="2783651"/>
+            <a:ext cx="1718563" cy="384255"/>
+          </a:xfrm>
+        </p:spPr>
+        <p:txBody>
+          <a:bodyPr>
+            <a:noAutofit/>
+          </a:bodyPr>
+          <a:lstStyle>
+            <a:lvl1pPr marL="0" indent="0" algn="ctr">
+              <a:buNone/>
+              <a:defRPr sz="2400" b="1"/>
+            </a:lvl1pPr>
+          </a:lstStyle>
+          <a:p>
+            <a:pPr lvl="0"/>
+            <a:r>
+              <a:rPr lang="en-US" dirty="0" smtClean="0"/>
+              <a:t>12345</a:t>
+            </a:r>
+            <a:endParaRPr lang="en-US" dirty="0"/>
+          </a:p>
+        </p:txBody>
+      </p:sp>
+      <p:sp>
+        <p:nvSpPr>
+          <p:cNvPr id="27" name="Text Placeholder 4"/>
+          <p:cNvSpPr>
+            <a:spLocks noGrp="1"/>
+          </p:cNvSpPr>
+          <p:nvPr>
+            <p:ph type="body" sz="quarter" idx="27" hasCustomPrompt="1"/>
+          </p:nvPr>
+        </p:nvSpPr>
+        <p:spPr>
+          <a:xfrm>
+            <a:off x="835533" y="3853842"/>
+            <a:ext cx="1718563" cy="384255"/>
+          </a:xfrm>
+        </p:spPr>
+        <p:txBody>
+          <a:bodyPr>
+            <a:noAutofit/>
+          </a:bodyPr>
+          <a:lstStyle>
+            <a:lvl1pPr marL="0" indent="0" algn="ctr">
+              <a:buNone/>
+              <a:defRPr sz="2400" b="1"/>
+            </a:lvl1pPr>
+          </a:lstStyle>
+          <a:p>
+            <a:pPr lvl="0"/>
+            <a:r>
+              <a:rPr lang="en-US" dirty="0" smtClean="0"/>
+              <a:t>12345</a:t>
+            </a:r>
+            <a:endParaRPr lang="en-US" dirty="0"/>
+          </a:p>
+        </p:txBody>
+      </p:sp>
+      <p:sp>
+        <p:nvSpPr>
+          <p:cNvPr id="33" name="TextBox 32"/>
+          <p:cNvSpPr txBox="1"/>
+          <p:nvPr userDrawn="1"/>
+        </p:nvSpPr>
+        <p:spPr>
+          <a:xfrm>
+            <a:off x="3606952" y="4204511"/>
+            <a:ext cx="808811" cy="338554"/>
+          </a:xfrm>
+          <a:prstGeom prst="rect">
+            <a:avLst/>
+          </a:prstGeom>
+          <a:noFill/>
+        </p:spPr>
+        <p:txBody>
+          <a:bodyPr wrap="none" rtlCol="0">
+            <a:spAutoFit/>
+          </a:bodyPr>
+          <a:lstStyle/>
+          <a:p>
+            <a:r>
+              <a:rPr lang="en-US" sz="1600" b="0" i="0" baseline="0" dirty="0" smtClean="0">
+                <a:solidFill>
+                  <a:schemeClr val="bg1">
+                    <a:lumMod val="65000"/>
+                  </a:schemeClr>
+                </a:solidFill>
+              </a:rPr>
+              <a:t>Neutral</a:t>
+            </a:r>
+            <a:endParaRPr lang="en-US" sz="1600" b="0" i="0" baseline="0" dirty="0">
+              <a:solidFill>
+                <a:schemeClr val="bg1">
+                  <a:lumMod val="65000"/>
+                </a:schemeClr>
+              </a:solidFill>
+            </a:endParaRPr>
+          </a:p>
+        </p:txBody>
+      </p:sp>
+      <p:sp>
+        <p:nvSpPr>
+          <p:cNvPr id="34" name="Text Placeholder 4"/>
+          <p:cNvSpPr>
+            <a:spLocks noGrp="1"/>
+          </p:cNvSpPr>
+          <p:nvPr>
+            <p:ph type="body" sz="quarter" idx="28" hasCustomPrompt="1"/>
+          </p:nvPr>
+        </p:nvSpPr>
+        <p:spPr>
+          <a:xfrm>
+            <a:off x="3188588" y="3853842"/>
+            <a:ext cx="1718563" cy="384255"/>
+          </a:xfrm>
+        </p:spPr>
+        <p:txBody>
+          <a:bodyPr>
+            <a:noAutofit/>
+          </a:bodyPr>
+          <a:lstStyle>
+            <a:lvl1pPr marL="0" indent="0" algn="ctr">
+              <a:buNone/>
+              <a:defRPr sz="2400" b="1"/>
+            </a:lvl1pPr>
+          </a:lstStyle>
+          <a:p>
+            <a:pPr lvl="0"/>
+            <a:r>
+              <a:rPr lang="en-US" dirty="0" smtClean="0"/>
+              <a:t>12345</a:t>
+            </a:r>
+            <a:endParaRPr lang="en-US" dirty="0"/>
+          </a:p>
+        </p:txBody>
+      </p:sp>
+      <p:sp>
+        <p:nvSpPr>
+          <p:cNvPr id="36" name="Rectangle 35"/>
+          <p:cNvSpPr/>
+          <p:nvPr userDrawn="1"/>
+        </p:nvSpPr>
+        <p:spPr>
+          <a:xfrm>
+            <a:off x="0" y="178825"/>
+            <a:ext cx="12192000" cy="540503"/>
+          </a:xfrm>
+          <a:prstGeom prst="rect">
+            <a:avLst/>
+          </a:prstGeom>
+          <a:solidFill>
+            <a:srgbClr val="F7F7F7"/>
+          </a:solidFill>
+          <a:ln>
+            <a:noFill/>
+          </a:ln>
+        </p:spPr>
+        <p:style>
+          <a:lnRef idx="2">
+            <a:schemeClr val="accent1">
+              <a:shade val="50000"/>
+            </a:schemeClr>
+          </a:lnRef>
+          <a:fillRef idx="1">
+            <a:schemeClr val="accent1"/>
+          </a:fillRef>
+          <a:effectRef idx="0">
+            <a:schemeClr val="accent1"/>
+          </a:effectRef>
+          <a:fontRef idx="minor">
+            <a:schemeClr val="lt1"/>
+          </a:fontRef>
+        </p:style>
+        <p:txBody>
+          <a:bodyPr rtlCol="0" anchor="ctr"/>
+          <a:lstStyle/>
+          <a:p>
+            <a:pPr algn="ctr"/>
+            <a:endParaRPr lang="en-US"/>
+          </a:p>
+        </p:txBody>
+      </p:sp>
+      <p:sp>
+        <p:nvSpPr>
+          <p:cNvPr id="37" name="Title 1"/>
+          <p:cNvSpPr>
+            <a:spLocks noGrp="1"/>
+          </p:cNvSpPr>
+          <p:nvPr>
+            <p:ph type="title" hasCustomPrompt="1"/>
+          </p:nvPr>
+        </p:nvSpPr>
+        <p:spPr>
+          <a:xfrm>
+            <a:off x="8534400" y="150559"/>
+            <a:ext cx="3049450" cy="548640"/>
+          </a:xfrm>
+          <a:solidFill>
+            <a:srgbClr val="F7F7F7"/>
+          </a:solidFill>
+          <a:ln>
+            <a:noFill/>
+          </a:ln>
+        </p:spPr>
+        <p:txBody>
+          <a:bodyPr>
+            <a:normAutofit/>
+          </a:bodyPr>
+          <a:lstStyle>
+            <a:lvl1pPr algn="r">
+              <a:defRPr sz="1600" baseline="0"/>
+            </a:lvl1pPr>
+          </a:lstStyle>
+          <a:p>
+            <a:r>
+              <a:rPr lang="en-US" dirty="0" smtClean="0"/>
+              <a:t>REPORT FOR</a:t>
+            </a:r>
+            <a:endParaRPr lang="en-US" dirty="0"/>
+          </a:p>
+        </p:txBody>
+      </p:sp>
+      <p:sp>
+        <p:nvSpPr>
+          <p:cNvPr id="38" name="Picture Placeholder 21"/>
+          <p:cNvSpPr>
+            <a:spLocks noGrp="1"/>
+          </p:cNvSpPr>
+          <p:nvPr>
+            <p:ph type="pic" sz="quarter" idx="12"/>
+          </p:nvPr>
+        </p:nvSpPr>
+        <p:spPr>
+          <a:xfrm>
+            <a:off x="849313" y="228929"/>
+            <a:ext cx="1814512" cy="441325"/>
+          </a:xfrm>
+        </p:spPr>
+        <p:txBody>
+          <a:bodyPr/>
+          <a:lstStyle/>
+          <a:p>
+            <a:endParaRPr lang="en-US" dirty="0"/>
+          </a:p>
+        </p:txBody>
+      </p:sp>
+    </p:spTree>
+    <p:extLst>
+      <p:ext uri="{BB962C8B-B14F-4D97-AF65-F5344CB8AC3E}">
+        <p14:creationId xmlns:p14="http://schemas.microsoft.com/office/powerpoint/2010/main" val="184407284"/>
+      </p:ext>
+    </p:extLst>
+  </p:cSld>
+  <p:clrMapOvr>
+    <a:masterClrMapping/>
+  </p:clrMapOvr>
+</p:sldLayout>
+</file>
+
+<file path=ppt/slideLayouts/slideLayout6.xml><?xml version="1.0" encoding="utf-8"?>
 <p:sldLayout xmlns:a="http://schemas.openxmlformats.org/drawingml/2006/main" xmlns:r="http://schemas.openxmlformats.org/officeDocument/2006/relationships" xmlns:p="http://schemas.openxmlformats.org/presentationml/2006/main" preserve="1" userDrawn="1">
   <p:cSld name="Side Chart Slide">
     <p:spTree>
@@ -1785,7 +2487,7 @@
 </p:sldLayout>
 </file>
 
-<file path=ppt/slideLayouts/slideLayout5.xml><?xml version="1.0" encoding="utf-8"?>
+<file path=ppt/slideLayouts/slideLayout7.xml><?xml version="1.0" encoding="utf-8"?>
 <p:sldLayout xmlns:a="http://schemas.openxmlformats.org/drawingml/2006/main" xmlns:r="http://schemas.openxmlformats.org/officeDocument/2006/relationships" xmlns:p="http://schemas.openxmlformats.org/presentationml/2006/main" preserve="1" userDrawn="1">
   <p:cSld name="Side Picture Slide">
     <p:spTree>
@@ -2049,7 +2751,7 @@
 </p:sldLayout>
 </file>
 
-<file path=ppt/slideLayouts/slideLayout6.xml><?xml version="1.0" encoding="utf-8"?>
+<file path=ppt/slideLayouts/slideLayout8.xml><?xml version="1.0" encoding="utf-8"?>
 <p:sldLayout xmlns:a="http://schemas.openxmlformats.org/drawingml/2006/main" xmlns:r="http://schemas.openxmlformats.org/officeDocument/2006/relationships" xmlns:p="http://schemas.openxmlformats.org/presentationml/2006/main" preserve="1" userDrawn="1">
   <p:cSld name="Mentions Slide">
     <p:spTree>
@@ -2639,7 +3341,7 @@
 </p:sldLayout>
 </file>
 
-<file path=ppt/slideLayouts/slideLayout7.xml><?xml version="1.0" encoding="utf-8"?>
+<file path=ppt/slideLayouts/slideLayout9.xml><?xml version="1.0" encoding="utf-8"?>
 <p:sldLayout xmlns:a="http://schemas.openxmlformats.org/drawingml/2006/main" xmlns:r="http://schemas.openxmlformats.org/officeDocument/2006/relationships" xmlns:p="http://schemas.openxmlformats.org/presentationml/2006/main" preserve="1" userDrawn="1">
   <p:cSld name="influencers Slide">
     <p:spTree>
@@ -4245,7 +4947,7 @@
           <a:p>
             <a:fld id="{AC74F5A4-8D5B-4493-9634-DA6247F7FBB6}" type="datetimeFigureOut">
               <a:rPr lang="en-US" smtClean="0"/>
-              <a:t>3/26/2025</a:t>
+              <a:t>4/1/2025</a:t>
             </a:fld>
             <a:endParaRPr lang="en-US"/>
           </a:p>
@@ -4339,12 +5041,14 @@
   <p:clrMap bg1="lt1" tx1="dk1" bg2="lt2" tx2="dk2" accent1="accent1" accent2="accent2" accent3="accent3" accent4="accent4" accent5="accent5" accent6="accent6" hlink="hlink" folHlink="folHlink"/>
   <p:sldLayoutIdLst>
     <p:sldLayoutId id="2147483649" r:id="rId1"/>
-    <p:sldLayoutId id="2147483650" r:id="rId2"/>
-    <p:sldLayoutId id="2147483663" r:id="rId3"/>
-    <p:sldLayoutId id="2147483661" r:id="rId4"/>
-    <p:sldLayoutId id="2147483666" r:id="rId5"/>
-    <p:sldLayoutId id="2147483662" r:id="rId6"/>
-    <p:sldLayoutId id="2147483665" r:id="rId7"/>
+    <p:sldLayoutId id="2147483668" r:id="rId2"/>
+    <p:sldLayoutId id="2147483650" r:id="rId3"/>
+    <p:sldLayoutId id="2147483663" r:id="rId4"/>
+    <p:sldLayoutId id="2147483667" r:id="rId5"/>
+    <p:sldLayoutId id="2147483661" r:id="rId6"/>
+    <p:sldLayoutId id="2147483666" r:id="rId7"/>
+    <p:sldLayoutId id="2147483662" r:id="rId8"/>
+    <p:sldLayoutId id="2147483665" r:id="rId9"/>
   </p:sldLayoutIdLst>
   <p:txStyles>
     <p:titleStyle>

</xml_diff>

<commit_message>
update: rename sentiment slide in pptx template
</commit_message>
<xml_diff>
--- a/app/reporters/ppt_generators/templates/ppt_template.pptx
+++ b/app/reporters/ppt_generators/templates/ppt_template.pptx
@@ -1585,7 +1585,7 @@
 
 <file path=ppt/slideLayouts/slideLayout5.xml><?xml version="1.0" encoding="utf-8"?>
 <p:sldLayout xmlns:a="http://schemas.openxmlformats.org/drawingml/2006/main" xmlns:r="http://schemas.openxmlformats.org/officeDocument/2006/relationships" xmlns:p="http://schemas.openxmlformats.org/presentationml/2006/main" preserve="1" userDrawn="1">
-  <p:cSld name="1_Sentiment Slide">
+  <p:cSld name="Sentiment Slide">
     <p:spTree>
       <p:nvGrpSpPr>
         <p:cNvPr id="1" name=""/>
@@ -1902,8 +1902,8 @@
         </p:nvSpPr>
         <p:spPr>
           <a:xfrm>
-            <a:off x="5479712" y="2388173"/>
-            <a:ext cx="6090495" cy="2933700"/>
+            <a:off x="5314422" y="2388173"/>
+            <a:ext cx="6255785" cy="2933700"/>
           </a:xfrm>
         </p:spPr>
         <p:txBody>

</xml_diff>